<commit_message>
Adopt candidate and certified braid terminology
</commit_message>
<xml_diff>
--- a/reference/archie/presentations/NPQG Assemblies - Early Life.pptx
+++ b/reference/archie/presentations/NPQG Assemblies - Early Life.pptx
@@ -8073,7 +8073,7 @@
 </file>
 
 <file path=ppt/slides/slide1.xml><?xml version="1.0" encoding="utf-8"?>
-<p:sld xmlns:a="http://schemas.openxmlformats.org/drawingml/2006/main" xmlns:r="http://schemas.openxmlformats.org/officeDocument/2006/relationships" xmlns:p="http://schemas.openxmlformats.org/presentationml/2006/main">
+<p:sld xmlns:a="http://schemas.openxmlformats.org/drawingml/2006/main" xmlns:a16="http://schemas.microsoft.com/office/drawing/2014/main" xmlns:ns3="http://schemas.microsoft.com/office/powerpoint/2010/main" xmlns:p="http://schemas.openxmlformats.org/presentationml/2006/main">
   <p:cSld>
     <p:bg>
       <p:bgPr>
@@ -8088,7 +8088,7 @@
         <p:cNvPr id="1" name="">
           <a:extLst>
             <a:ext uri="{FF2B5EF4-FFF2-40B4-BE49-F238E27FC236}">
-              <a16:creationId xmlns:a16="http://schemas.microsoft.com/office/drawing/2014/main" id="{A95AD505-148F-7C13-EC73-22518E14F4FC}"/>
+              <a16:creationId id="{A95AD505-148F-7C13-EC73-22518E14F4FC}"/>
             </a:ext>
           </a:extLst>
         </p:cNvPr>
@@ -8108,7 +8108,7 @@
           <p:cNvPr id="2" name="TextBox 1">
             <a:extLst>
               <a:ext uri="{FF2B5EF4-FFF2-40B4-BE49-F238E27FC236}">
-                <a16:creationId xmlns:a16="http://schemas.microsoft.com/office/drawing/2014/main" id="{B3C53938-22FE-22BD-E59A-97F76192783B}"/>
+                <a16:creationId id="{B3C53938-22FE-22BD-E59A-97F76192783B}"/>
               </a:ext>
             </a:extLst>
           </p:cNvPr>
@@ -8232,7 +8232,7 @@
                 <a:ea typeface="Helvetica Neue Condensed Black" panose="02000503000000020004" pitchFamily="2" charset="0"/>
                 <a:cs typeface="Helvetica Neue Condensed Black" panose="02000503000000020004" pitchFamily="2" charset="0"/>
               </a:rPr>
-              <a:t>Point Potentials?</a:t>
+              <a:t>Architrinos?</a:t>
             </a:r>
             <a:endParaRPr kumimoji="0" lang="en-US" sz="11500" b="1" i="0" u="none" strike="noStrike" kern="1200" cap="none" spc="0" normalizeH="0" baseline="0" noProof="0" dirty="0">
               <a:ln>
@@ -8251,10 +8251,166 @@
           </a:p>
         </p:txBody>
       </p:sp>
+      <p:sp>
+        <p:nvSpPr>
+          <p:cNvPr id="3" name="Footer Placeholder 3"/>
+          <p:cNvSpPr txBox="1">
+            <a:spLocks/>
+          </p:cNvSpPr>
+          <p:nvPr/>
+        </p:nvSpPr>
+        <p:spPr>
+          <a:xfrm>
+            <a:off x="10942204" y="6481737"/>
+            <a:ext cx="1217443" cy="365125"/>
+          </a:xfrm>
+          <a:prstGeom prst="rect">
+            <a:avLst/>
+          </a:prstGeom>
+        </p:spPr>
+        <p:txBody>
+          <a:bodyPr vert="horz" lIns="91440" tIns="45720" rIns="91440" bIns="45720" rtlCol="0" anchor="ctr"/>
+          <a:lstStyle>
+            <a:defPPr>
+              <a:defRPr lang="en-US"/>
+            </a:defPPr>
+            <a:lvl1pPr marL="0" algn="ctr" defTabSz="914400" rtl="0" eaLnBrk="1" latinLnBrk="0" hangingPunct="1">
+              <a:defRPr sz="1200" kern="1200">
+                <a:solidFill>
+                  <a:schemeClr val="tx1">
+                    <a:tint val="75000"/>
+                  </a:schemeClr>
+                </a:solidFill>
+                <a:latin typeface="+mn-lt"/>
+                <a:ea typeface="+mn-ea"/>
+                <a:cs typeface="+mn-cs"/>
+              </a:defRPr>
+            </a:lvl1pPr>
+            <a:lvl2pPr marL="457200" algn="l" defTabSz="914400" rtl="0" eaLnBrk="1" latinLnBrk="0" hangingPunct="1">
+              <a:defRPr sz="1800" kern="1200">
+                <a:solidFill>
+                  <a:schemeClr val="tx1"/>
+                </a:solidFill>
+                <a:latin typeface="+mn-lt"/>
+                <a:ea typeface="+mn-ea"/>
+                <a:cs typeface="+mn-cs"/>
+              </a:defRPr>
+            </a:lvl2pPr>
+            <a:lvl3pPr marL="914400" algn="l" defTabSz="914400" rtl="0" eaLnBrk="1" latinLnBrk="0" hangingPunct="1">
+              <a:defRPr sz="1800" kern="1200">
+                <a:solidFill>
+                  <a:schemeClr val="tx1"/>
+                </a:solidFill>
+                <a:latin typeface="+mn-lt"/>
+                <a:ea typeface="+mn-ea"/>
+                <a:cs typeface="+mn-cs"/>
+              </a:defRPr>
+            </a:lvl3pPr>
+            <a:lvl4pPr marL="1371600" algn="l" defTabSz="914400" rtl="0" eaLnBrk="1" latinLnBrk="0" hangingPunct="1">
+              <a:defRPr sz="1800" kern="1200">
+                <a:solidFill>
+                  <a:schemeClr val="tx1"/>
+                </a:solidFill>
+                <a:latin typeface="+mn-lt"/>
+                <a:ea typeface="+mn-ea"/>
+                <a:cs typeface="+mn-cs"/>
+              </a:defRPr>
+            </a:lvl4pPr>
+            <a:lvl5pPr marL="1828800" algn="l" defTabSz="914400" rtl="0" eaLnBrk="1" latinLnBrk="0" hangingPunct="1">
+              <a:defRPr sz="1800" kern="1200">
+                <a:solidFill>
+                  <a:schemeClr val="tx1"/>
+                </a:solidFill>
+                <a:latin typeface="+mn-lt"/>
+                <a:ea typeface="+mn-ea"/>
+                <a:cs typeface="+mn-cs"/>
+              </a:defRPr>
+            </a:lvl5pPr>
+            <a:lvl6pPr marL="2286000" algn="l" defTabSz="914400" rtl="0" eaLnBrk="1" latinLnBrk="0" hangingPunct="1">
+              <a:defRPr sz="1800" kern="1200">
+                <a:solidFill>
+                  <a:schemeClr val="tx1"/>
+                </a:solidFill>
+                <a:latin typeface="+mn-lt"/>
+                <a:ea typeface="+mn-ea"/>
+                <a:cs typeface="+mn-cs"/>
+              </a:defRPr>
+            </a:lvl6pPr>
+            <a:lvl7pPr marL="2743200" algn="l" defTabSz="914400" rtl="0" eaLnBrk="1" latinLnBrk="0" hangingPunct="1">
+              <a:defRPr sz="1800" kern="1200">
+                <a:solidFill>
+                  <a:schemeClr val="tx1"/>
+                </a:solidFill>
+                <a:latin typeface="+mn-lt"/>
+                <a:ea typeface="+mn-ea"/>
+                <a:cs typeface="+mn-cs"/>
+              </a:defRPr>
+            </a:lvl7pPr>
+            <a:lvl8pPr marL="3200400" algn="l" defTabSz="914400" rtl="0" eaLnBrk="1" latinLnBrk="0" hangingPunct="1">
+              <a:defRPr sz="1800" kern="1200">
+                <a:solidFill>
+                  <a:schemeClr val="tx1"/>
+                </a:solidFill>
+                <a:latin typeface="+mn-lt"/>
+                <a:ea typeface="+mn-ea"/>
+                <a:cs typeface="+mn-cs"/>
+              </a:defRPr>
+            </a:lvl8pPr>
+            <a:lvl9pPr marL="3657600" algn="l" defTabSz="914400" rtl="0" eaLnBrk="1" latinLnBrk="0" hangingPunct="1">
+              <a:defRPr sz="1800" kern="1200">
+                <a:solidFill>
+                  <a:schemeClr val="tx1"/>
+                </a:solidFill>
+                <a:latin typeface="+mn-lt"/>
+                <a:ea typeface="+mn-ea"/>
+                <a:cs typeface="+mn-cs"/>
+              </a:defRPr>
+            </a:lvl9pPr>
+          </a:lstStyle>
+          <a:p>
+            <a:pPr marL="0" marR="0" lvl="0" indent="0" algn="ctr" defTabSz="914400" rtl="0" eaLnBrk="1" fontAlgn="auto" latinLnBrk="0" hangingPunct="1">
+              <a:lnSpc>
+                <a:spcPct val="100000"/>
+              </a:lnSpc>
+              <a:spcBef>
+                <a:spcPts val="0"/>
+              </a:spcBef>
+              <a:spcAft>
+                <a:spcPts val="0"/>
+              </a:spcAft>
+              <a:buClrTx/>
+              <a:buSzTx/>
+              <a:buFontTx/>
+              <a:buNone/>
+              <a:tabLst/>
+              <a:defRPr/>
+            </a:pPr>
+            <a:r>
+              <a:rPr kumimoji="0" lang="en-US" sz="1200" b="0" i="0" u="none" strike="noStrike" kern="1200" cap="none" spc="0" normalizeH="0" baseline="0" noProof="0" dirty="0">
+                <a:ln>
+                  <a:noFill/>
+                </a:ln>
+                <a:solidFill>
+                  <a:prstClr val="black">
+                    <a:tint val="75000"/>
+                  </a:prstClr>
+                </a:solidFill>
+                <a:effectLst/>
+                <a:uLnTx/>
+                <a:uFillTx/>
+                <a:latin typeface="Helvetica Neue" panose="02000503000000020004" pitchFamily="2" charset="0"/>
+                <a:ea typeface="Helvetica Neue" panose="02000503000000020004" pitchFamily="2" charset="0"/>
+                <a:cs typeface="Helvetica Neue" panose="02000503000000020004" pitchFamily="2" charset="0"/>
+              </a:rPr>
+              <a:t>architrino.com</a:t>
+            </a:r>
+          </a:p>
+        </p:txBody>
+      </p:sp>
     </p:spTree>
     <p:extLst>
       <p:ext uri="{BB962C8B-B14F-4D97-AF65-F5344CB8AC3E}">
-        <p14:creationId xmlns:p14="http://schemas.microsoft.com/office/powerpoint/2010/main" val="3311713244"/>
+        <ns3:creationId val="3311713244"/>
       </p:ext>
     </p:extLst>
   </p:cSld>
@@ -8265,7 +8421,7 @@
 </file>
 
 <file path=ppt/slides/slide2.xml><?xml version="1.0" encoding="utf-8"?>
-<p:sld xmlns:a="http://schemas.openxmlformats.org/drawingml/2006/main" xmlns:r="http://schemas.openxmlformats.org/officeDocument/2006/relationships" xmlns:p="http://schemas.openxmlformats.org/presentationml/2006/main">
+<p:sld xmlns:a="http://schemas.openxmlformats.org/drawingml/2006/main" xmlns:a16="http://schemas.microsoft.com/office/drawing/2014/main" xmlns:ns4="http://schemas.microsoft.com/office/drawing/2010/main" xmlns:ns5="http://schemas.microsoft.com/office/powerpoint/2010/main" xmlns:p="http://schemas.openxmlformats.org/presentationml/2006/main" xmlns:r="http://schemas.openxmlformats.org/officeDocument/2006/relationships">
   <p:cSld>
     <p:bg>
       <p:bgPr>
@@ -8280,7 +8436,7 @@
         <p:cNvPr id="1" name="">
           <a:extLst>
             <a:ext uri="{FF2B5EF4-FFF2-40B4-BE49-F238E27FC236}">
-              <a16:creationId xmlns:a16="http://schemas.microsoft.com/office/drawing/2014/main" id="{365CF149-638E-D4FE-A688-5F738F294DCE}"/>
+              <a16:creationId id="{365CF149-638E-D4FE-A688-5F738F294DCE}"/>
             </a:ext>
           </a:extLst>
         </p:cNvPr>
@@ -8300,7 +8456,7 @@
           <p:cNvPr id="2" name="TextBox 1">
             <a:extLst>
               <a:ext uri="{FF2B5EF4-FFF2-40B4-BE49-F238E27FC236}">
-                <a16:creationId xmlns:a16="http://schemas.microsoft.com/office/drawing/2014/main" id="{CA22E71C-3B43-3887-6804-C1009A7A1619}"/>
+                <a16:creationId id="{CA22E71C-3B43-3887-6804-C1009A7A1619}"/>
               </a:ext>
             </a:extLst>
           </p:cNvPr>
@@ -8402,7 +8558,7 @@
           <p:cNvPr id="5" name="TextBox 4">
             <a:extLst>
               <a:ext uri="{FF2B5EF4-FFF2-40B4-BE49-F238E27FC236}">
-                <a16:creationId xmlns:a16="http://schemas.microsoft.com/office/drawing/2014/main" id="{9FD60923-3051-E75C-EBA1-5F01B55BA37A}"/>
+                <a16:creationId id="{9FD60923-3051-E75C-EBA1-5F01B55BA37A}"/>
               </a:ext>
             </a:extLst>
           </p:cNvPr>
@@ -8616,7 +8772,7 @@
                 <a:ea typeface="Helvetica Neue" panose="02000503000000020004" pitchFamily="2" charset="0"/>
                 <a:cs typeface="Helvetica Neue" panose="02000503000000020004" pitchFamily="2" charset="0"/>
               </a:rPr>
-              <a:t> 4K-6K point potentials.</a:t>
+              <a:t> 4K-6K architrinos.</a:t>
             </a:r>
           </a:p>
           <a:p>
@@ -8634,7 +8790,7 @@
                 <a:ea typeface="Helvetica Neue" panose="02000503000000020004" pitchFamily="2" charset="0"/>
                 <a:cs typeface="Helvetica Neue" panose="02000503000000020004" pitchFamily="2" charset="0"/>
               </a:rPr>
-              <a:t>The genome therefore contains 500K x 10K ~= 5B point potentials.</a:t>
+              <a:t>The genome therefore contains 500K x 10K ~= 5B architrinos.</a:t>
             </a:r>
           </a:p>
           <a:p>
@@ -8902,7 +9058,7 @@
           <p:cNvPr id="3074" name="Picture 2" descr="undefined">
             <a:extLst>
               <a:ext uri="{FF2B5EF4-FFF2-40B4-BE49-F238E27FC236}">
-                <a16:creationId xmlns:a16="http://schemas.microsoft.com/office/drawing/2014/main" id="{446818C8-F552-491F-947A-ACEDA4EBAFB1}"/>
+                <a16:creationId id="{446818C8-F552-491F-947A-ACEDA4EBAFB1}"/>
               </a:ext>
             </a:extLst>
           </p:cNvPr>
@@ -8915,7 +9071,7 @@
           <a:blip r:embed="rId3">
             <a:extLst>
               <a:ext uri="{28A0092B-C50C-407E-A947-70E740481C1C}">
-                <a14:useLocalDpi xmlns:a14="http://schemas.microsoft.com/office/drawing/2010/main" val="0"/>
+                <ns4:useLocalDpi val="0"/>
               </a:ext>
             </a:extLst>
           </a:blip>
@@ -8935,19 +9091,175 @@
           <a:noFill/>
           <a:extLst>
             <a:ext uri="{909E8E84-426E-40DD-AFC4-6F175D3DCCD1}">
-              <a14:hiddenFill xmlns:a14="http://schemas.microsoft.com/office/drawing/2010/main">
+              <ns4:hiddenFill>
                 <a:solidFill>
                   <a:srgbClr val="FFFFFF"/>
                 </a:solidFill>
-              </a14:hiddenFill>
+              </ns4:hiddenFill>
             </a:ext>
           </a:extLst>
         </p:spPr>
       </p:pic>
+      <p:sp>
+        <p:nvSpPr>
+          <p:cNvPr id="3" name="Footer Placeholder 3"/>
+          <p:cNvSpPr txBox="1">
+            <a:spLocks/>
+          </p:cNvSpPr>
+          <p:nvPr/>
+        </p:nvSpPr>
+        <p:spPr>
+          <a:xfrm>
+            <a:off x="10942204" y="6481737"/>
+            <a:ext cx="1217443" cy="365125"/>
+          </a:xfrm>
+          <a:prstGeom prst="rect">
+            <a:avLst/>
+          </a:prstGeom>
+        </p:spPr>
+        <p:txBody>
+          <a:bodyPr vert="horz" lIns="91440" tIns="45720" rIns="91440" bIns="45720" rtlCol="0" anchor="ctr"/>
+          <a:lstStyle>
+            <a:defPPr>
+              <a:defRPr lang="en-US"/>
+            </a:defPPr>
+            <a:lvl1pPr marL="0" algn="ctr" defTabSz="914400" rtl="0" eaLnBrk="1" latinLnBrk="0" hangingPunct="1">
+              <a:defRPr sz="1200" kern="1200">
+                <a:solidFill>
+                  <a:schemeClr val="tx1">
+                    <a:tint val="75000"/>
+                  </a:schemeClr>
+                </a:solidFill>
+                <a:latin typeface="+mn-lt"/>
+                <a:ea typeface="+mn-ea"/>
+                <a:cs typeface="+mn-cs"/>
+              </a:defRPr>
+            </a:lvl1pPr>
+            <a:lvl2pPr marL="457200" algn="l" defTabSz="914400" rtl="0" eaLnBrk="1" latinLnBrk="0" hangingPunct="1">
+              <a:defRPr sz="1800" kern="1200">
+                <a:solidFill>
+                  <a:schemeClr val="tx1"/>
+                </a:solidFill>
+                <a:latin typeface="+mn-lt"/>
+                <a:ea typeface="+mn-ea"/>
+                <a:cs typeface="+mn-cs"/>
+              </a:defRPr>
+            </a:lvl2pPr>
+            <a:lvl3pPr marL="914400" algn="l" defTabSz="914400" rtl="0" eaLnBrk="1" latinLnBrk="0" hangingPunct="1">
+              <a:defRPr sz="1800" kern="1200">
+                <a:solidFill>
+                  <a:schemeClr val="tx1"/>
+                </a:solidFill>
+                <a:latin typeface="+mn-lt"/>
+                <a:ea typeface="+mn-ea"/>
+                <a:cs typeface="+mn-cs"/>
+              </a:defRPr>
+            </a:lvl3pPr>
+            <a:lvl4pPr marL="1371600" algn="l" defTabSz="914400" rtl="0" eaLnBrk="1" latinLnBrk="0" hangingPunct="1">
+              <a:defRPr sz="1800" kern="1200">
+                <a:solidFill>
+                  <a:schemeClr val="tx1"/>
+                </a:solidFill>
+                <a:latin typeface="+mn-lt"/>
+                <a:ea typeface="+mn-ea"/>
+                <a:cs typeface="+mn-cs"/>
+              </a:defRPr>
+            </a:lvl4pPr>
+            <a:lvl5pPr marL="1828800" algn="l" defTabSz="914400" rtl="0" eaLnBrk="1" latinLnBrk="0" hangingPunct="1">
+              <a:defRPr sz="1800" kern="1200">
+                <a:solidFill>
+                  <a:schemeClr val="tx1"/>
+                </a:solidFill>
+                <a:latin typeface="+mn-lt"/>
+                <a:ea typeface="+mn-ea"/>
+                <a:cs typeface="+mn-cs"/>
+              </a:defRPr>
+            </a:lvl5pPr>
+            <a:lvl6pPr marL="2286000" algn="l" defTabSz="914400" rtl="0" eaLnBrk="1" latinLnBrk="0" hangingPunct="1">
+              <a:defRPr sz="1800" kern="1200">
+                <a:solidFill>
+                  <a:schemeClr val="tx1"/>
+                </a:solidFill>
+                <a:latin typeface="+mn-lt"/>
+                <a:ea typeface="+mn-ea"/>
+                <a:cs typeface="+mn-cs"/>
+              </a:defRPr>
+            </a:lvl6pPr>
+            <a:lvl7pPr marL="2743200" algn="l" defTabSz="914400" rtl="0" eaLnBrk="1" latinLnBrk="0" hangingPunct="1">
+              <a:defRPr sz="1800" kern="1200">
+                <a:solidFill>
+                  <a:schemeClr val="tx1"/>
+                </a:solidFill>
+                <a:latin typeface="+mn-lt"/>
+                <a:ea typeface="+mn-ea"/>
+                <a:cs typeface="+mn-cs"/>
+              </a:defRPr>
+            </a:lvl7pPr>
+            <a:lvl8pPr marL="3200400" algn="l" defTabSz="914400" rtl="0" eaLnBrk="1" latinLnBrk="0" hangingPunct="1">
+              <a:defRPr sz="1800" kern="1200">
+                <a:solidFill>
+                  <a:schemeClr val="tx1"/>
+                </a:solidFill>
+                <a:latin typeface="+mn-lt"/>
+                <a:ea typeface="+mn-ea"/>
+                <a:cs typeface="+mn-cs"/>
+              </a:defRPr>
+            </a:lvl8pPr>
+            <a:lvl9pPr marL="3657600" algn="l" defTabSz="914400" rtl="0" eaLnBrk="1" latinLnBrk="0" hangingPunct="1">
+              <a:defRPr sz="1800" kern="1200">
+                <a:solidFill>
+                  <a:schemeClr val="tx1"/>
+                </a:solidFill>
+                <a:latin typeface="+mn-lt"/>
+                <a:ea typeface="+mn-ea"/>
+                <a:cs typeface="+mn-cs"/>
+              </a:defRPr>
+            </a:lvl9pPr>
+          </a:lstStyle>
+          <a:p>
+            <a:pPr marL="0" marR="0" lvl="0" indent="0" algn="ctr" defTabSz="914400" rtl="0" eaLnBrk="1" fontAlgn="auto" latinLnBrk="0" hangingPunct="1">
+              <a:lnSpc>
+                <a:spcPct val="100000"/>
+              </a:lnSpc>
+              <a:spcBef>
+                <a:spcPts val="0"/>
+              </a:spcBef>
+              <a:spcAft>
+                <a:spcPts val="0"/>
+              </a:spcAft>
+              <a:buClrTx/>
+              <a:buSzTx/>
+              <a:buFontTx/>
+              <a:buNone/>
+              <a:tabLst/>
+              <a:defRPr/>
+            </a:pPr>
+            <a:r>
+              <a:rPr kumimoji="0" lang="en-US" sz="1200" b="0" i="0" u="none" strike="noStrike" kern="1200" cap="none" spc="0" normalizeH="0" baseline="0" noProof="0" dirty="0">
+                <a:ln>
+                  <a:noFill/>
+                </a:ln>
+                <a:solidFill>
+                  <a:prstClr val="black">
+                    <a:tint val="75000"/>
+                  </a:prstClr>
+                </a:solidFill>
+                <a:effectLst/>
+                <a:uLnTx/>
+                <a:uFillTx/>
+                <a:latin typeface="Helvetica Neue" panose="02000503000000020004" pitchFamily="2" charset="0"/>
+                <a:ea typeface="Helvetica Neue" panose="02000503000000020004" pitchFamily="2" charset="0"/>
+                <a:cs typeface="Helvetica Neue" panose="02000503000000020004" pitchFamily="2" charset="0"/>
+              </a:rPr>
+              <a:t>architrino.com</a:t>
+            </a:r>
+          </a:p>
+        </p:txBody>
+      </p:sp>
     </p:spTree>
     <p:extLst>
       <p:ext uri="{BB962C8B-B14F-4D97-AF65-F5344CB8AC3E}">
-        <p14:creationId xmlns:p14="http://schemas.microsoft.com/office/powerpoint/2010/main" val="3325331473"/>
+        <ns5:creationId val="3325331473"/>
       </p:ext>
     </p:extLst>
   </p:cSld>
@@ -8958,7 +9270,7 @@
 </file>
 
 <file path=ppt/slides/slide3.xml><?xml version="1.0" encoding="utf-8"?>
-<p:sld xmlns:a="http://schemas.openxmlformats.org/drawingml/2006/main" xmlns:r="http://schemas.openxmlformats.org/officeDocument/2006/relationships" xmlns:p="http://schemas.openxmlformats.org/presentationml/2006/main">
+<p:sld xmlns:a="http://schemas.openxmlformats.org/drawingml/2006/main" xmlns:a16="http://schemas.microsoft.com/office/drawing/2014/main" xmlns:ns4="http://schemas.microsoft.com/office/drawing/2010/main" xmlns:ns5="http://schemas.microsoft.com/office/powerpoint/2010/main" xmlns:p="http://schemas.openxmlformats.org/presentationml/2006/main" xmlns:r="http://schemas.openxmlformats.org/officeDocument/2006/relationships">
   <p:cSld>
     <p:bg>
       <p:bgPr>
@@ -8973,7 +9285,7 @@
         <p:cNvPr id="1" name="">
           <a:extLst>
             <a:ext uri="{FF2B5EF4-FFF2-40B4-BE49-F238E27FC236}">
-              <a16:creationId xmlns:a16="http://schemas.microsoft.com/office/drawing/2014/main" id="{A711A77B-062A-BD38-03C1-60CB4990FB5B}"/>
+              <a16:creationId id="{A711A77B-062A-BD38-03C1-60CB4990FB5B}"/>
             </a:ext>
           </a:extLst>
         </p:cNvPr>
@@ -8993,7 +9305,7 @@
           <p:cNvPr id="2" name="TextBox 1">
             <a:extLst>
               <a:ext uri="{FF2B5EF4-FFF2-40B4-BE49-F238E27FC236}">
-                <a16:creationId xmlns:a16="http://schemas.microsoft.com/office/drawing/2014/main" id="{50904127-1953-FD93-0848-CFD145C7CE67}"/>
+                <a16:creationId id="{50904127-1953-FD93-0848-CFD145C7CE67}"/>
               </a:ext>
             </a:extLst>
           </p:cNvPr>
@@ -9089,7 +9401,7 @@
           <p:cNvPr id="5" name="TextBox 4">
             <a:extLst>
               <a:ext uri="{FF2B5EF4-FFF2-40B4-BE49-F238E27FC236}">
-                <a16:creationId xmlns:a16="http://schemas.microsoft.com/office/drawing/2014/main" id="{5A4BFBEF-ACE4-2284-D65B-A6DB0D04FC01}"/>
+                <a16:creationId id="{5A4BFBEF-ACE4-2284-D65B-A6DB0D04FC01}"/>
               </a:ext>
             </a:extLst>
           </p:cNvPr>
@@ -9847,7 +10159,7 @@
           <p:cNvPr id="9" name="Picture 2">
             <a:extLst>
               <a:ext uri="{FF2B5EF4-FFF2-40B4-BE49-F238E27FC236}">
-                <a16:creationId xmlns:a16="http://schemas.microsoft.com/office/drawing/2014/main" id="{9E983575-73C1-C2AA-EAB2-22F5A2F20397}"/>
+                <a16:creationId id="{9E983575-73C1-C2AA-EAB2-22F5A2F20397}"/>
               </a:ext>
             </a:extLst>
           </p:cNvPr>
@@ -9860,7 +10172,7 @@
           <a:blip r:embed="rId3">
             <a:extLst>
               <a:ext uri="{28A0092B-C50C-407E-A947-70E740481C1C}">
-                <a14:useLocalDpi xmlns:a14="http://schemas.microsoft.com/office/drawing/2010/main" val="0"/>
+                <ns4:useLocalDpi val="0"/>
               </a:ext>
             </a:extLst>
           </a:blip>
@@ -9880,19 +10192,175 @@
           <a:noFill/>
           <a:extLst>
             <a:ext uri="{909E8E84-426E-40DD-AFC4-6F175D3DCCD1}">
-              <a14:hiddenFill xmlns:a14="http://schemas.microsoft.com/office/drawing/2010/main">
+              <ns4:hiddenFill>
                 <a:solidFill>
                   <a:srgbClr val="FFFFFF"/>
                 </a:solidFill>
-              </a14:hiddenFill>
+              </ns4:hiddenFill>
             </a:ext>
           </a:extLst>
         </p:spPr>
       </p:pic>
+      <p:sp>
+        <p:nvSpPr>
+          <p:cNvPr id="3" name="Footer Placeholder 3"/>
+          <p:cNvSpPr txBox="1">
+            <a:spLocks/>
+          </p:cNvSpPr>
+          <p:nvPr/>
+        </p:nvSpPr>
+        <p:spPr>
+          <a:xfrm>
+            <a:off x="10942204" y="6481737"/>
+            <a:ext cx="1217443" cy="365125"/>
+          </a:xfrm>
+          <a:prstGeom prst="rect">
+            <a:avLst/>
+          </a:prstGeom>
+        </p:spPr>
+        <p:txBody>
+          <a:bodyPr vert="horz" lIns="91440" tIns="45720" rIns="91440" bIns="45720" rtlCol="0" anchor="ctr"/>
+          <a:lstStyle>
+            <a:defPPr>
+              <a:defRPr lang="en-US"/>
+            </a:defPPr>
+            <a:lvl1pPr marL="0" algn="ctr" defTabSz="914400" rtl="0" eaLnBrk="1" latinLnBrk="0" hangingPunct="1">
+              <a:defRPr sz="1200" kern="1200">
+                <a:solidFill>
+                  <a:schemeClr val="tx1">
+                    <a:tint val="75000"/>
+                  </a:schemeClr>
+                </a:solidFill>
+                <a:latin typeface="+mn-lt"/>
+                <a:ea typeface="+mn-ea"/>
+                <a:cs typeface="+mn-cs"/>
+              </a:defRPr>
+            </a:lvl1pPr>
+            <a:lvl2pPr marL="457200" algn="l" defTabSz="914400" rtl="0" eaLnBrk="1" latinLnBrk="0" hangingPunct="1">
+              <a:defRPr sz="1800" kern="1200">
+                <a:solidFill>
+                  <a:schemeClr val="tx1"/>
+                </a:solidFill>
+                <a:latin typeface="+mn-lt"/>
+                <a:ea typeface="+mn-ea"/>
+                <a:cs typeface="+mn-cs"/>
+              </a:defRPr>
+            </a:lvl2pPr>
+            <a:lvl3pPr marL="914400" algn="l" defTabSz="914400" rtl="0" eaLnBrk="1" latinLnBrk="0" hangingPunct="1">
+              <a:defRPr sz="1800" kern="1200">
+                <a:solidFill>
+                  <a:schemeClr val="tx1"/>
+                </a:solidFill>
+                <a:latin typeface="+mn-lt"/>
+                <a:ea typeface="+mn-ea"/>
+                <a:cs typeface="+mn-cs"/>
+              </a:defRPr>
+            </a:lvl3pPr>
+            <a:lvl4pPr marL="1371600" algn="l" defTabSz="914400" rtl="0" eaLnBrk="1" latinLnBrk="0" hangingPunct="1">
+              <a:defRPr sz="1800" kern="1200">
+                <a:solidFill>
+                  <a:schemeClr val="tx1"/>
+                </a:solidFill>
+                <a:latin typeface="+mn-lt"/>
+                <a:ea typeface="+mn-ea"/>
+                <a:cs typeface="+mn-cs"/>
+              </a:defRPr>
+            </a:lvl4pPr>
+            <a:lvl5pPr marL="1828800" algn="l" defTabSz="914400" rtl="0" eaLnBrk="1" latinLnBrk="0" hangingPunct="1">
+              <a:defRPr sz="1800" kern="1200">
+                <a:solidFill>
+                  <a:schemeClr val="tx1"/>
+                </a:solidFill>
+                <a:latin typeface="+mn-lt"/>
+                <a:ea typeface="+mn-ea"/>
+                <a:cs typeface="+mn-cs"/>
+              </a:defRPr>
+            </a:lvl5pPr>
+            <a:lvl6pPr marL="2286000" algn="l" defTabSz="914400" rtl="0" eaLnBrk="1" latinLnBrk="0" hangingPunct="1">
+              <a:defRPr sz="1800" kern="1200">
+                <a:solidFill>
+                  <a:schemeClr val="tx1"/>
+                </a:solidFill>
+                <a:latin typeface="+mn-lt"/>
+                <a:ea typeface="+mn-ea"/>
+                <a:cs typeface="+mn-cs"/>
+              </a:defRPr>
+            </a:lvl6pPr>
+            <a:lvl7pPr marL="2743200" algn="l" defTabSz="914400" rtl="0" eaLnBrk="1" latinLnBrk="0" hangingPunct="1">
+              <a:defRPr sz="1800" kern="1200">
+                <a:solidFill>
+                  <a:schemeClr val="tx1"/>
+                </a:solidFill>
+                <a:latin typeface="+mn-lt"/>
+                <a:ea typeface="+mn-ea"/>
+                <a:cs typeface="+mn-cs"/>
+              </a:defRPr>
+            </a:lvl7pPr>
+            <a:lvl8pPr marL="3200400" algn="l" defTabSz="914400" rtl="0" eaLnBrk="1" latinLnBrk="0" hangingPunct="1">
+              <a:defRPr sz="1800" kern="1200">
+                <a:solidFill>
+                  <a:schemeClr val="tx1"/>
+                </a:solidFill>
+                <a:latin typeface="+mn-lt"/>
+                <a:ea typeface="+mn-ea"/>
+                <a:cs typeface="+mn-cs"/>
+              </a:defRPr>
+            </a:lvl8pPr>
+            <a:lvl9pPr marL="3657600" algn="l" defTabSz="914400" rtl="0" eaLnBrk="1" latinLnBrk="0" hangingPunct="1">
+              <a:defRPr sz="1800" kern="1200">
+                <a:solidFill>
+                  <a:schemeClr val="tx1"/>
+                </a:solidFill>
+                <a:latin typeface="+mn-lt"/>
+                <a:ea typeface="+mn-ea"/>
+                <a:cs typeface="+mn-cs"/>
+              </a:defRPr>
+            </a:lvl9pPr>
+          </a:lstStyle>
+          <a:p>
+            <a:pPr marL="0" marR="0" lvl="0" indent="0" algn="ctr" defTabSz="914400" rtl="0" eaLnBrk="1" fontAlgn="auto" latinLnBrk="0" hangingPunct="1">
+              <a:lnSpc>
+                <a:spcPct val="100000"/>
+              </a:lnSpc>
+              <a:spcBef>
+                <a:spcPts val="0"/>
+              </a:spcBef>
+              <a:spcAft>
+                <a:spcPts val="0"/>
+              </a:spcAft>
+              <a:buClrTx/>
+              <a:buSzTx/>
+              <a:buFontTx/>
+              <a:buNone/>
+              <a:tabLst/>
+              <a:defRPr/>
+            </a:pPr>
+            <a:r>
+              <a:rPr kumimoji="0" lang="en-US" sz="1200" b="0" i="0" u="none" strike="noStrike" kern="1200" cap="none" spc="0" normalizeH="0" baseline="0" noProof="0" dirty="0">
+                <a:ln>
+                  <a:noFill/>
+                </a:ln>
+                <a:solidFill>
+                  <a:prstClr val="black">
+                    <a:tint val="75000"/>
+                  </a:prstClr>
+                </a:solidFill>
+                <a:effectLst/>
+                <a:uLnTx/>
+                <a:uFillTx/>
+                <a:latin typeface="Helvetica Neue" panose="02000503000000020004" pitchFamily="2" charset="0"/>
+                <a:ea typeface="Helvetica Neue" panose="02000503000000020004" pitchFamily="2" charset="0"/>
+                <a:cs typeface="Helvetica Neue" panose="02000503000000020004" pitchFamily="2" charset="0"/>
+              </a:rPr>
+              <a:t>architrino.com</a:t>
+            </a:r>
+          </a:p>
+        </p:txBody>
+      </p:sp>
     </p:spTree>
     <p:extLst>
       <p:ext uri="{BB962C8B-B14F-4D97-AF65-F5344CB8AC3E}">
-        <p14:creationId xmlns:p14="http://schemas.microsoft.com/office/powerpoint/2010/main" val="2649105293"/>
+        <ns5:creationId val="2649105293"/>
       </p:ext>
     </p:extLst>
   </p:cSld>
@@ -9903,7 +10371,7 @@
 </file>
 
 <file path=ppt/slides/slide4.xml><?xml version="1.0" encoding="utf-8"?>
-<p:sld xmlns:a="http://schemas.openxmlformats.org/drawingml/2006/main" xmlns:r="http://schemas.openxmlformats.org/officeDocument/2006/relationships" xmlns:p="http://schemas.openxmlformats.org/presentationml/2006/main">
+<p:sld xmlns:a="http://schemas.openxmlformats.org/drawingml/2006/main" xmlns:a16="http://schemas.microsoft.com/office/drawing/2014/main" xmlns:ns3="http://schemas.microsoft.com/office/powerpoint/2010/main" xmlns:p="http://schemas.openxmlformats.org/presentationml/2006/main">
   <p:cSld>
     <p:bg>
       <p:bgPr>
@@ -9918,7 +10386,7 @@
         <p:cNvPr id="1" name="">
           <a:extLst>
             <a:ext uri="{FF2B5EF4-FFF2-40B4-BE49-F238E27FC236}">
-              <a16:creationId xmlns:a16="http://schemas.microsoft.com/office/drawing/2014/main" id="{BBFBF43E-80A4-D013-5C64-AD16BBE309A9}"/>
+              <a16:creationId id="{BBFBF43E-80A4-D013-5C64-AD16BBE309A9}"/>
             </a:ext>
           </a:extLst>
         </p:cNvPr>
@@ -9938,7 +10406,7 @@
           <p:cNvPr id="2" name="TextBox 1">
             <a:extLst>
               <a:ext uri="{FF2B5EF4-FFF2-40B4-BE49-F238E27FC236}">
-                <a16:creationId xmlns:a16="http://schemas.microsoft.com/office/drawing/2014/main" id="{DF4E743A-E740-B9E8-D400-EA3F32FF1D55}"/>
+                <a16:creationId id="{DF4E743A-E740-B9E8-D400-EA3F32FF1D55}"/>
               </a:ext>
             </a:extLst>
           </p:cNvPr>
@@ -10034,7 +10502,7 @@
           <p:cNvPr id="5" name="TextBox 4">
             <a:extLst>
               <a:ext uri="{FF2B5EF4-FFF2-40B4-BE49-F238E27FC236}">
-                <a16:creationId xmlns:a16="http://schemas.microsoft.com/office/drawing/2014/main" id="{42082ECC-CEEB-D2B8-60C0-FAF5A1857737}"/>
+                <a16:creationId id="{42082ECC-CEEB-D2B8-60C0-FAF5A1857737}"/>
               </a:ext>
             </a:extLst>
           </p:cNvPr>
@@ -10949,10 +11417,166 @@
           </a:p>
         </p:txBody>
       </p:sp>
+      <p:sp>
+        <p:nvSpPr>
+          <p:cNvPr id="3" name="Footer Placeholder 3"/>
+          <p:cNvSpPr txBox="1">
+            <a:spLocks/>
+          </p:cNvSpPr>
+          <p:nvPr/>
+        </p:nvSpPr>
+        <p:spPr>
+          <a:xfrm>
+            <a:off x="10942204" y="6481737"/>
+            <a:ext cx="1217443" cy="365125"/>
+          </a:xfrm>
+          <a:prstGeom prst="rect">
+            <a:avLst/>
+          </a:prstGeom>
+        </p:spPr>
+        <p:txBody>
+          <a:bodyPr vert="horz" lIns="91440" tIns="45720" rIns="91440" bIns="45720" rtlCol="0" anchor="ctr"/>
+          <a:lstStyle>
+            <a:defPPr>
+              <a:defRPr lang="en-US"/>
+            </a:defPPr>
+            <a:lvl1pPr marL="0" algn="ctr" defTabSz="914400" rtl="0" eaLnBrk="1" latinLnBrk="0" hangingPunct="1">
+              <a:defRPr sz="1200" kern="1200">
+                <a:solidFill>
+                  <a:schemeClr val="tx1">
+                    <a:tint val="75000"/>
+                  </a:schemeClr>
+                </a:solidFill>
+                <a:latin typeface="+mn-lt"/>
+                <a:ea typeface="+mn-ea"/>
+                <a:cs typeface="+mn-cs"/>
+              </a:defRPr>
+            </a:lvl1pPr>
+            <a:lvl2pPr marL="457200" algn="l" defTabSz="914400" rtl="0" eaLnBrk="1" latinLnBrk="0" hangingPunct="1">
+              <a:defRPr sz="1800" kern="1200">
+                <a:solidFill>
+                  <a:schemeClr val="tx1"/>
+                </a:solidFill>
+                <a:latin typeface="+mn-lt"/>
+                <a:ea typeface="+mn-ea"/>
+                <a:cs typeface="+mn-cs"/>
+              </a:defRPr>
+            </a:lvl2pPr>
+            <a:lvl3pPr marL="914400" algn="l" defTabSz="914400" rtl="0" eaLnBrk="1" latinLnBrk="0" hangingPunct="1">
+              <a:defRPr sz="1800" kern="1200">
+                <a:solidFill>
+                  <a:schemeClr val="tx1"/>
+                </a:solidFill>
+                <a:latin typeface="+mn-lt"/>
+                <a:ea typeface="+mn-ea"/>
+                <a:cs typeface="+mn-cs"/>
+              </a:defRPr>
+            </a:lvl3pPr>
+            <a:lvl4pPr marL="1371600" algn="l" defTabSz="914400" rtl="0" eaLnBrk="1" latinLnBrk="0" hangingPunct="1">
+              <a:defRPr sz="1800" kern="1200">
+                <a:solidFill>
+                  <a:schemeClr val="tx1"/>
+                </a:solidFill>
+                <a:latin typeface="+mn-lt"/>
+                <a:ea typeface="+mn-ea"/>
+                <a:cs typeface="+mn-cs"/>
+              </a:defRPr>
+            </a:lvl4pPr>
+            <a:lvl5pPr marL="1828800" algn="l" defTabSz="914400" rtl="0" eaLnBrk="1" latinLnBrk="0" hangingPunct="1">
+              <a:defRPr sz="1800" kern="1200">
+                <a:solidFill>
+                  <a:schemeClr val="tx1"/>
+                </a:solidFill>
+                <a:latin typeface="+mn-lt"/>
+                <a:ea typeface="+mn-ea"/>
+                <a:cs typeface="+mn-cs"/>
+              </a:defRPr>
+            </a:lvl5pPr>
+            <a:lvl6pPr marL="2286000" algn="l" defTabSz="914400" rtl="0" eaLnBrk="1" latinLnBrk="0" hangingPunct="1">
+              <a:defRPr sz="1800" kern="1200">
+                <a:solidFill>
+                  <a:schemeClr val="tx1"/>
+                </a:solidFill>
+                <a:latin typeface="+mn-lt"/>
+                <a:ea typeface="+mn-ea"/>
+                <a:cs typeface="+mn-cs"/>
+              </a:defRPr>
+            </a:lvl6pPr>
+            <a:lvl7pPr marL="2743200" algn="l" defTabSz="914400" rtl="0" eaLnBrk="1" latinLnBrk="0" hangingPunct="1">
+              <a:defRPr sz="1800" kern="1200">
+                <a:solidFill>
+                  <a:schemeClr val="tx1"/>
+                </a:solidFill>
+                <a:latin typeface="+mn-lt"/>
+                <a:ea typeface="+mn-ea"/>
+                <a:cs typeface="+mn-cs"/>
+              </a:defRPr>
+            </a:lvl7pPr>
+            <a:lvl8pPr marL="3200400" algn="l" defTabSz="914400" rtl="0" eaLnBrk="1" latinLnBrk="0" hangingPunct="1">
+              <a:defRPr sz="1800" kern="1200">
+                <a:solidFill>
+                  <a:schemeClr val="tx1"/>
+                </a:solidFill>
+                <a:latin typeface="+mn-lt"/>
+                <a:ea typeface="+mn-ea"/>
+                <a:cs typeface="+mn-cs"/>
+              </a:defRPr>
+            </a:lvl8pPr>
+            <a:lvl9pPr marL="3657600" algn="l" defTabSz="914400" rtl="0" eaLnBrk="1" latinLnBrk="0" hangingPunct="1">
+              <a:defRPr sz="1800" kern="1200">
+                <a:solidFill>
+                  <a:schemeClr val="tx1"/>
+                </a:solidFill>
+                <a:latin typeface="+mn-lt"/>
+                <a:ea typeface="+mn-ea"/>
+                <a:cs typeface="+mn-cs"/>
+              </a:defRPr>
+            </a:lvl9pPr>
+          </a:lstStyle>
+          <a:p>
+            <a:pPr marL="0" marR="0" lvl="0" indent="0" algn="ctr" defTabSz="914400" rtl="0" eaLnBrk="1" fontAlgn="auto" latinLnBrk="0" hangingPunct="1">
+              <a:lnSpc>
+                <a:spcPct val="100000"/>
+              </a:lnSpc>
+              <a:spcBef>
+                <a:spcPts val="0"/>
+              </a:spcBef>
+              <a:spcAft>
+                <a:spcPts val="0"/>
+              </a:spcAft>
+              <a:buClrTx/>
+              <a:buSzTx/>
+              <a:buFontTx/>
+              <a:buNone/>
+              <a:tabLst/>
+              <a:defRPr/>
+            </a:pPr>
+            <a:r>
+              <a:rPr kumimoji="0" lang="en-US" sz="1200" b="0" i="0" u="none" strike="noStrike" kern="1200" cap="none" spc="0" normalizeH="0" baseline="0" noProof="0" dirty="0">
+                <a:ln>
+                  <a:noFill/>
+                </a:ln>
+                <a:solidFill>
+                  <a:prstClr val="black">
+                    <a:tint val="75000"/>
+                  </a:prstClr>
+                </a:solidFill>
+                <a:effectLst/>
+                <a:uLnTx/>
+                <a:uFillTx/>
+                <a:latin typeface="Helvetica Neue" panose="02000503000000020004" pitchFamily="2" charset="0"/>
+                <a:ea typeface="Helvetica Neue" panose="02000503000000020004" pitchFamily="2" charset="0"/>
+                <a:cs typeface="Helvetica Neue" panose="02000503000000020004" pitchFamily="2" charset="0"/>
+              </a:rPr>
+              <a:t>architrino.com</a:t>
+            </a:r>
+          </a:p>
+        </p:txBody>
+      </p:sp>
     </p:spTree>
     <p:extLst>
       <p:ext uri="{BB962C8B-B14F-4D97-AF65-F5344CB8AC3E}">
-        <p14:creationId xmlns:p14="http://schemas.microsoft.com/office/powerpoint/2010/main" val="3863008067"/>
+        <ns3:creationId val="3863008067"/>
       </p:ext>
     </p:extLst>
   </p:cSld>
@@ -10963,7 +11587,7 @@
 </file>
 
 <file path=ppt/slides/slide5.xml><?xml version="1.0" encoding="utf-8"?>
-<p:sld xmlns:a="http://schemas.openxmlformats.org/drawingml/2006/main" xmlns:r="http://schemas.openxmlformats.org/officeDocument/2006/relationships" xmlns:p="http://schemas.openxmlformats.org/presentationml/2006/main">
+<p:sld xmlns:a="http://schemas.openxmlformats.org/drawingml/2006/main" xmlns:a16="http://schemas.microsoft.com/office/drawing/2014/main" xmlns:ns3="http://schemas.microsoft.com/office/powerpoint/2010/main" xmlns:ns4="http://schemas.openxmlformats.org/drawingml/2006/diagram" xmlns:p="http://schemas.openxmlformats.org/presentationml/2006/main" xmlns:r="http://schemas.openxmlformats.org/officeDocument/2006/relationships">
   <p:cSld>
     <p:bg>
       <p:bgPr>
@@ -10978,7 +11602,7 @@
         <p:cNvPr id="1" name="">
           <a:extLst>
             <a:ext uri="{FF2B5EF4-FFF2-40B4-BE49-F238E27FC236}">
-              <a16:creationId xmlns:a16="http://schemas.microsoft.com/office/drawing/2014/main" id="{1453722B-3781-0E08-25A9-7EDF71C96246}"/>
+              <a16:creationId id="{1453722B-3781-0E08-25A9-7EDF71C96246}"/>
             </a:ext>
           </a:extLst>
         </p:cNvPr>
@@ -10998,7 +11622,7 @@
           <p:cNvPr id="3" name="Diagram 2">
             <a:extLst>
               <a:ext uri="{FF2B5EF4-FFF2-40B4-BE49-F238E27FC236}">
-                <a16:creationId xmlns:a16="http://schemas.microsoft.com/office/drawing/2014/main" id="{64AD777F-D0D7-80D3-EA3B-8A560D8BC354}"/>
+                <a16:creationId id="{64AD777F-D0D7-80D3-EA3B-8A560D8BC354}"/>
               </a:ext>
             </a:extLst>
           </p:cNvPr>
@@ -11006,7 +11630,7 @@
           <p:nvPr>
             <p:extLst>
               <p:ext uri="{D42A27DB-BD31-4B8C-83A1-F6EECF244321}">
-                <p14:modId xmlns:p14="http://schemas.microsoft.com/office/powerpoint/2010/main" val="4232438656"/>
+                <ns3:modId val="4232438656"/>
               </p:ext>
             </p:extLst>
           </p:nvPr>
@@ -11017,7 +11641,7 @@
         </p:xfrm>
         <a:graphic>
           <a:graphicData uri="http://schemas.openxmlformats.org/drawingml/2006/diagram">
-            <dgm:relIds xmlns:dgm="http://schemas.openxmlformats.org/drawingml/2006/diagram" xmlns:r="http://schemas.openxmlformats.org/officeDocument/2006/relationships" r:dm="rId3" r:lo="rId4" r:qs="rId5" r:cs="rId6"/>
+            <ns4:relIds r:dm="rId3" r:lo="rId4" r:qs="rId5" r:cs="rId6"/>
           </a:graphicData>
         </a:graphic>
       </p:graphicFrame>
@@ -11026,7 +11650,7 @@
           <p:cNvPr id="4" name="TextBox 3">
             <a:extLst>
               <a:ext uri="{FF2B5EF4-FFF2-40B4-BE49-F238E27FC236}">
-                <a16:creationId xmlns:a16="http://schemas.microsoft.com/office/drawing/2014/main" id="{8B0D959F-1F8C-C85F-60B5-2379D17C87E3}"/>
+                <a16:creationId id="{8B0D959F-1F8C-C85F-60B5-2379D17C87E3}"/>
               </a:ext>
             </a:extLst>
           </p:cNvPr>
@@ -11237,7 +11861,163 @@
                 <a:ea typeface="Helvetica Neue" panose="02000503000000020004" pitchFamily="2" charset="0"/>
                 <a:cs typeface="Helvetica Neue" panose="02000503000000020004" pitchFamily="2" charset="0"/>
               </a:rPr>
-              <a:t> point potentials</a:t>
+              <a:t> architrinos</a:t>
+            </a:r>
+          </a:p>
+        </p:txBody>
+      </p:sp>
+      <p:sp>
+        <p:nvSpPr>
+          <p:cNvPr id="5" name="Footer Placeholder 3"/>
+          <p:cNvSpPr txBox="1">
+            <a:spLocks/>
+          </p:cNvSpPr>
+          <p:nvPr/>
+        </p:nvSpPr>
+        <p:spPr>
+          <a:xfrm>
+            <a:off x="10942204" y="6481737"/>
+            <a:ext cx="1217443" cy="365125"/>
+          </a:xfrm>
+          <a:prstGeom prst="rect">
+            <a:avLst/>
+          </a:prstGeom>
+        </p:spPr>
+        <p:txBody>
+          <a:bodyPr vert="horz" lIns="91440" tIns="45720" rIns="91440" bIns="45720" rtlCol="0" anchor="ctr"/>
+          <a:lstStyle>
+            <a:defPPr>
+              <a:defRPr lang="en-US"/>
+            </a:defPPr>
+            <a:lvl1pPr marL="0" algn="ctr" defTabSz="914400" rtl="0" eaLnBrk="1" latinLnBrk="0" hangingPunct="1">
+              <a:defRPr sz="1200" kern="1200">
+                <a:solidFill>
+                  <a:schemeClr val="tx1">
+                    <a:tint val="75000"/>
+                  </a:schemeClr>
+                </a:solidFill>
+                <a:latin typeface="+mn-lt"/>
+                <a:ea typeface="+mn-ea"/>
+                <a:cs typeface="+mn-cs"/>
+              </a:defRPr>
+            </a:lvl1pPr>
+            <a:lvl2pPr marL="457200" algn="l" defTabSz="914400" rtl="0" eaLnBrk="1" latinLnBrk="0" hangingPunct="1">
+              <a:defRPr sz="1800" kern="1200">
+                <a:solidFill>
+                  <a:schemeClr val="tx1"/>
+                </a:solidFill>
+                <a:latin typeface="+mn-lt"/>
+                <a:ea typeface="+mn-ea"/>
+                <a:cs typeface="+mn-cs"/>
+              </a:defRPr>
+            </a:lvl2pPr>
+            <a:lvl3pPr marL="914400" algn="l" defTabSz="914400" rtl="0" eaLnBrk="1" latinLnBrk="0" hangingPunct="1">
+              <a:defRPr sz="1800" kern="1200">
+                <a:solidFill>
+                  <a:schemeClr val="tx1"/>
+                </a:solidFill>
+                <a:latin typeface="+mn-lt"/>
+                <a:ea typeface="+mn-ea"/>
+                <a:cs typeface="+mn-cs"/>
+              </a:defRPr>
+            </a:lvl3pPr>
+            <a:lvl4pPr marL="1371600" algn="l" defTabSz="914400" rtl="0" eaLnBrk="1" latinLnBrk="0" hangingPunct="1">
+              <a:defRPr sz="1800" kern="1200">
+                <a:solidFill>
+                  <a:schemeClr val="tx1"/>
+                </a:solidFill>
+                <a:latin typeface="+mn-lt"/>
+                <a:ea typeface="+mn-ea"/>
+                <a:cs typeface="+mn-cs"/>
+              </a:defRPr>
+            </a:lvl4pPr>
+            <a:lvl5pPr marL="1828800" algn="l" defTabSz="914400" rtl="0" eaLnBrk="1" latinLnBrk="0" hangingPunct="1">
+              <a:defRPr sz="1800" kern="1200">
+                <a:solidFill>
+                  <a:schemeClr val="tx1"/>
+                </a:solidFill>
+                <a:latin typeface="+mn-lt"/>
+                <a:ea typeface="+mn-ea"/>
+                <a:cs typeface="+mn-cs"/>
+              </a:defRPr>
+            </a:lvl5pPr>
+            <a:lvl6pPr marL="2286000" algn="l" defTabSz="914400" rtl="0" eaLnBrk="1" latinLnBrk="0" hangingPunct="1">
+              <a:defRPr sz="1800" kern="1200">
+                <a:solidFill>
+                  <a:schemeClr val="tx1"/>
+                </a:solidFill>
+                <a:latin typeface="+mn-lt"/>
+                <a:ea typeface="+mn-ea"/>
+                <a:cs typeface="+mn-cs"/>
+              </a:defRPr>
+            </a:lvl6pPr>
+            <a:lvl7pPr marL="2743200" algn="l" defTabSz="914400" rtl="0" eaLnBrk="1" latinLnBrk="0" hangingPunct="1">
+              <a:defRPr sz="1800" kern="1200">
+                <a:solidFill>
+                  <a:schemeClr val="tx1"/>
+                </a:solidFill>
+                <a:latin typeface="+mn-lt"/>
+                <a:ea typeface="+mn-ea"/>
+                <a:cs typeface="+mn-cs"/>
+              </a:defRPr>
+            </a:lvl7pPr>
+            <a:lvl8pPr marL="3200400" algn="l" defTabSz="914400" rtl="0" eaLnBrk="1" latinLnBrk="0" hangingPunct="1">
+              <a:defRPr sz="1800" kern="1200">
+                <a:solidFill>
+                  <a:schemeClr val="tx1"/>
+                </a:solidFill>
+                <a:latin typeface="+mn-lt"/>
+                <a:ea typeface="+mn-ea"/>
+                <a:cs typeface="+mn-cs"/>
+              </a:defRPr>
+            </a:lvl8pPr>
+            <a:lvl9pPr marL="3657600" algn="l" defTabSz="914400" rtl="0" eaLnBrk="1" latinLnBrk="0" hangingPunct="1">
+              <a:defRPr sz="1800" kern="1200">
+                <a:solidFill>
+                  <a:schemeClr val="tx1"/>
+                </a:solidFill>
+                <a:latin typeface="+mn-lt"/>
+                <a:ea typeface="+mn-ea"/>
+                <a:cs typeface="+mn-cs"/>
+              </a:defRPr>
+            </a:lvl9pPr>
+          </a:lstStyle>
+          <a:p>
+            <a:pPr marL="0" marR="0" lvl="0" indent="0" algn="ctr" defTabSz="914400" rtl="0" eaLnBrk="1" fontAlgn="auto" latinLnBrk="0" hangingPunct="1">
+              <a:lnSpc>
+                <a:spcPct val="100000"/>
+              </a:lnSpc>
+              <a:spcBef>
+                <a:spcPts val="0"/>
+              </a:spcBef>
+              <a:spcAft>
+                <a:spcPts val="0"/>
+              </a:spcAft>
+              <a:buClrTx/>
+              <a:buSzTx/>
+              <a:buFontTx/>
+              <a:buNone/>
+              <a:tabLst/>
+              <a:defRPr/>
+            </a:pPr>
+            <a:r>
+              <a:rPr kumimoji="0" lang="en-US" sz="1200" b="0" i="0" u="none" strike="noStrike" kern="1200" cap="none" spc="0" normalizeH="0" baseline="0" noProof="0" dirty="0">
+                <a:ln>
+                  <a:noFill/>
+                </a:ln>
+                <a:solidFill>
+                  <a:prstClr val="black">
+                    <a:tint val="75000"/>
+                  </a:prstClr>
+                </a:solidFill>
+                <a:effectLst/>
+                <a:uLnTx/>
+                <a:uFillTx/>
+                <a:latin typeface="Helvetica Neue" panose="02000503000000020004" pitchFamily="2" charset="0"/>
+                <a:ea typeface="Helvetica Neue" panose="02000503000000020004" pitchFamily="2" charset="0"/>
+                <a:cs typeface="Helvetica Neue" panose="02000503000000020004" pitchFamily="2" charset="0"/>
+              </a:rPr>
+              <a:t>architrino.com</a:t>
             </a:r>
           </a:p>
         </p:txBody>
@@ -11245,7 +12025,7 @@
     </p:spTree>
     <p:extLst>
       <p:ext uri="{BB962C8B-B14F-4D97-AF65-F5344CB8AC3E}">
-        <p14:creationId xmlns:p14="http://schemas.microsoft.com/office/powerpoint/2010/main" val="213017330"/>
+        <ns3:creationId val="213017330"/>
       </p:ext>
     </p:extLst>
   </p:cSld>

</xml_diff>

<commit_message>
Add NPQG time and space presentation assets
</commit_message>
<xml_diff>
--- a/reference/archie/presentations/NPQG Assemblies - Early Life.pptx
+++ b/reference/archie/presentations/NPQG Assemblies - Early Life.pptx
@@ -8073,7 +8073,7 @@
 </file>
 
 <file path=ppt/slides/slide1.xml><?xml version="1.0" encoding="utf-8"?>
-<p:sld xmlns:a="http://schemas.openxmlformats.org/drawingml/2006/main" xmlns:a16="http://schemas.microsoft.com/office/drawing/2014/main" xmlns:ns3="http://schemas.microsoft.com/office/powerpoint/2010/main" xmlns:p="http://schemas.openxmlformats.org/presentationml/2006/main">
+<p:sld xmlns:a="http://schemas.openxmlformats.org/drawingml/2006/main" xmlns:r="http://schemas.openxmlformats.org/officeDocument/2006/relationships" xmlns:p="http://schemas.openxmlformats.org/presentationml/2006/main">
   <p:cSld>
     <p:bg>
       <p:bgPr>
@@ -8088,7 +8088,7 @@
         <p:cNvPr id="1" name="">
           <a:extLst>
             <a:ext uri="{FF2B5EF4-FFF2-40B4-BE49-F238E27FC236}">
-              <a16:creationId id="{A95AD505-148F-7C13-EC73-22518E14F4FC}"/>
+              <a16:creationId xmlns:a16="http://schemas.microsoft.com/office/drawing/2014/main" id="{A95AD505-148F-7C13-EC73-22518E14F4FC}"/>
             </a:ext>
           </a:extLst>
         </p:cNvPr>
@@ -8108,7 +8108,7 @@
           <p:cNvPr id="2" name="TextBox 1">
             <a:extLst>
               <a:ext uri="{FF2B5EF4-FFF2-40B4-BE49-F238E27FC236}">
-                <a16:creationId id="{B3C53938-22FE-22BD-E59A-97F76192783B}"/>
+                <a16:creationId xmlns:a16="http://schemas.microsoft.com/office/drawing/2014/main" id="{B3C53938-22FE-22BD-E59A-97F76192783B}"/>
               </a:ext>
             </a:extLst>
           </p:cNvPr>
@@ -8117,7 +8117,7 @@
         </p:nvSpPr>
         <p:spPr>
           <a:xfrm>
-            <a:off x="0" y="186247"/>
+            <a:off x="0" y="858908"/>
             <a:ext cx="12191999" cy="3953968"/>
           </a:xfrm>
           <a:prstGeom prst="rect">
@@ -8410,7 +8410,7 @@
     </p:spTree>
     <p:extLst>
       <p:ext uri="{BB962C8B-B14F-4D97-AF65-F5344CB8AC3E}">
-        <ns3:creationId val="3311713244"/>
+        <p14:creationId xmlns:p14="http://schemas.microsoft.com/office/powerpoint/2010/main" val="3311713244"/>
       </p:ext>
     </p:extLst>
   </p:cSld>
@@ -8421,7 +8421,7 @@
 </file>
 
 <file path=ppt/slides/slide2.xml><?xml version="1.0" encoding="utf-8"?>
-<p:sld xmlns:a="http://schemas.openxmlformats.org/drawingml/2006/main" xmlns:a16="http://schemas.microsoft.com/office/drawing/2014/main" xmlns:ns4="http://schemas.microsoft.com/office/drawing/2010/main" xmlns:ns5="http://schemas.microsoft.com/office/powerpoint/2010/main" xmlns:p="http://schemas.openxmlformats.org/presentationml/2006/main" xmlns:r="http://schemas.openxmlformats.org/officeDocument/2006/relationships">
+<p:sld xmlns:a="http://schemas.openxmlformats.org/drawingml/2006/main" xmlns:r="http://schemas.openxmlformats.org/officeDocument/2006/relationships" xmlns:p="http://schemas.openxmlformats.org/presentationml/2006/main">
   <p:cSld>
     <p:bg>
       <p:bgPr>
@@ -8436,7 +8436,7 @@
         <p:cNvPr id="1" name="">
           <a:extLst>
             <a:ext uri="{FF2B5EF4-FFF2-40B4-BE49-F238E27FC236}">
-              <a16:creationId id="{365CF149-638E-D4FE-A688-5F738F294DCE}"/>
+              <a16:creationId xmlns:a16="http://schemas.microsoft.com/office/drawing/2014/main" id="{365CF149-638E-D4FE-A688-5F738F294DCE}"/>
             </a:ext>
           </a:extLst>
         </p:cNvPr>
@@ -8456,7 +8456,7 @@
           <p:cNvPr id="2" name="TextBox 1">
             <a:extLst>
               <a:ext uri="{FF2B5EF4-FFF2-40B4-BE49-F238E27FC236}">
-                <a16:creationId id="{CA22E71C-3B43-3887-6804-C1009A7A1619}"/>
+                <a16:creationId xmlns:a16="http://schemas.microsoft.com/office/drawing/2014/main" id="{CA22E71C-3B43-3887-6804-C1009A7A1619}"/>
               </a:ext>
             </a:extLst>
           </p:cNvPr>
@@ -8558,7 +8558,7 @@
           <p:cNvPr id="5" name="TextBox 4">
             <a:extLst>
               <a:ext uri="{FF2B5EF4-FFF2-40B4-BE49-F238E27FC236}">
-                <a16:creationId id="{9FD60923-3051-E75C-EBA1-5F01B55BA37A}"/>
+                <a16:creationId xmlns:a16="http://schemas.microsoft.com/office/drawing/2014/main" id="{9FD60923-3051-E75C-EBA1-5F01B55BA37A}"/>
               </a:ext>
             </a:extLst>
           </p:cNvPr>
@@ -9058,7 +9058,7 @@
           <p:cNvPr id="3074" name="Picture 2" descr="undefined">
             <a:extLst>
               <a:ext uri="{FF2B5EF4-FFF2-40B4-BE49-F238E27FC236}">
-                <a16:creationId id="{446818C8-F552-491F-947A-ACEDA4EBAFB1}"/>
+                <a16:creationId xmlns:a16="http://schemas.microsoft.com/office/drawing/2014/main" id="{446818C8-F552-491F-947A-ACEDA4EBAFB1}"/>
               </a:ext>
             </a:extLst>
           </p:cNvPr>
@@ -9071,7 +9071,7 @@
           <a:blip r:embed="rId3">
             <a:extLst>
               <a:ext uri="{28A0092B-C50C-407E-A947-70E740481C1C}">
-                <ns4:useLocalDpi val="0"/>
+                <a14:useLocalDpi xmlns:a14="http://schemas.microsoft.com/office/drawing/2010/main" val="0"/>
               </a:ext>
             </a:extLst>
           </a:blip>
@@ -9091,11 +9091,11 @@
           <a:noFill/>
           <a:extLst>
             <a:ext uri="{909E8E84-426E-40DD-AFC4-6F175D3DCCD1}">
-              <ns4:hiddenFill>
+              <a14:hiddenFill xmlns:a14="http://schemas.microsoft.com/office/drawing/2010/main">
                 <a:solidFill>
                   <a:srgbClr val="FFFFFF"/>
                 </a:solidFill>
-              </ns4:hiddenFill>
+              </a14:hiddenFill>
             </a:ext>
           </a:extLst>
         </p:spPr>
@@ -9259,7 +9259,7 @@
     </p:spTree>
     <p:extLst>
       <p:ext uri="{BB962C8B-B14F-4D97-AF65-F5344CB8AC3E}">
-        <ns5:creationId val="3325331473"/>
+        <p14:creationId xmlns:p14="http://schemas.microsoft.com/office/powerpoint/2010/main" val="3325331473"/>
       </p:ext>
     </p:extLst>
   </p:cSld>
@@ -9270,7 +9270,7 @@
 </file>
 
 <file path=ppt/slides/slide3.xml><?xml version="1.0" encoding="utf-8"?>
-<p:sld xmlns:a="http://schemas.openxmlformats.org/drawingml/2006/main" xmlns:a16="http://schemas.microsoft.com/office/drawing/2014/main" xmlns:ns4="http://schemas.microsoft.com/office/drawing/2010/main" xmlns:ns5="http://schemas.microsoft.com/office/powerpoint/2010/main" xmlns:p="http://schemas.openxmlformats.org/presentationml/2006/main" xmlns:r="http://schemas.openxmlformats.org/officeDocument/2006/relationships">
+<p:sld xmlns:a="http://schemas.openxmlformats.org/drawingml/2006/main" xmlns:r="http://schemas.openxmlformats.org/officeDocument/2006/relationships" xmlns:p="http://schemas.openxmlformats.org/presentationml/2006/main">
   <p:cSld>
     <p:bg>
       <p:bgPr>
@@ -9285,7 +9285,7 @@
         <p:cNvPr id="1" name="">
           <a:extLst>
             <a:ext uri="{FF2B5EF4-FFF2-40B4-BE49-F238E27FC236}">
-              <a16:creationId id="{A711A77B-062A-BD38-03C1-60CB4990FB5B}"/>
+              <a16:creationId xmlns:a16="http://schemas.microsoft.com/office/drawing/2014/main" id="{A711A77B-062A-BD38-03C1-60CB4990FB5B}"/>
             </a:ext>
           </a:extLst>
         </p:cNvPr>
@@ -9305,7 +9305,7 @@
           <p:cNvPr id="2" name="TextBox 1">
             <a:extLst>
               <a:ext uri="{FF2B5EF4-FFF2-40B4-BE49-F238E27FC236}">
-                <a16:creationId id="{50904127-1953-FD93-0848-CFD145C7CE67}"/>
+                <a16:creationId xmlns:a16="http://schemas.microsoft.com/office/drawing/2014/main" id="{50904127-1953-FD93-0848-CFD145C7CE67}"/>
               </a:ext>
             </a:extLst>
           </p:cNvPr>
@@ -9401,7 +9401,7 @@
           <p:cNvPr id="5" name="TextBox 4">
             <a:extLst>
               <a:ext uri="{FF2B5EF4-FFF2-40B4-BE49-F238E27FC236}">
-                <a16:creationId id="{5A4BFBEF-ACE4-2284-D65B-A6DB0D04FC01}"/>
+                <a16:creationId xmlns:a16="http://schemas.microsoft.com/office/drawing/2014/main" id="{5A4BFBEF-ACE4-2284-D65B-A6DB0D04FC01}"/>
               </a:ext>
             </a:extLst>
           </p:cNvPr>
@@ -10159,7 +10159,7 @@
           <p:cNvPr id="9" name="Picture 2">
             <a:extLst>
               <a:ext uri="{FF2B5EF4-FFF2-40B4-BE49-F238E27FC236}">
-                <a16:creationId id="{9E983575-73C1-C2AA-EAB2-22F5A2F20397}"/>
+                <a16:creationId xmlns:a16="http://schemas.microsoft.com/office/drawing/2014/main" id="{9E983575-73C1-C2AA-EAB2-22F5A2F20397}"/>
               </a:ext>
             </a:extLst>
           </p:cNvPr>
@@ -10172,7 +10172,7 @@
           <a:blip r:embed="rId3">
             <a:extLst>
               <a:ext uri="{28A0092B-C50C-407E-A947-70E740481C1C}">
-                <ns4:useLocalDpi val="0"/>
+                <a14:useLocalDpi xmlns:a14="http://schemas.microsoft.com/office/drawing/2010/main" val="0"/>
               </a:ext>
             </a:extLst>
           </a:blip>
@@ -10192,11 +10192,11 @@
           <a:noFill/>
           <a:extLst>
             <a:ext uri="{909E8E84-426E-40DD-AFC4-6F175D3DCCD1}">
-              <ns4:hiddenFill>
+              <a14:hiddenFill xmlns:a14="http://schemas.microsoft.com/office/drawing/2010/main">
                 <a:solidFill>
                   <a:srgbClr val="FFFFFF"/>
                 </a:solidFill>
-              </ns4:hiddenFill>
+              </a14:hiddenFill>
             </a:ext>
           </a:extLst>
         </p:spPr>
@@ -10360,7 +10360,7 @@
     </p:spTree>
     <p:extLst>
       <p:ext uri="{BB962C8B-B14F-4D97-AF65-F5344CB8AC3E}">
-        <ns5:creationId val="2649105293"/>
+        <p14:creationId xmlns:p14="http://schemas.microsoft.com/office/powerpoint/2010/main" val="2649105293"/>
       </p:ext>
     </p:extLst>
   </p:cSld>
@@ -10371,7 +10371,7 @@
 </file>
 
 <file path=ppt/slides/slide4.xml><?xml version="1.0" encoding="utf-8"?>
-<p:sld xmlns:a="http://schemas.openxmlformats.org/drawingml/2006/main" xmlns:a16="http://schemas.microsoft.com/office/drawing/2014/main" xmlns:ns3="http://schemas.microsoft.com/office/powerpoint/2010/main" xmlns:p="http://schemas.openxmlformats.org/presentationml/2006/main">
+<p:sld xmlns:a="http://schemas.openxmlformats.org/drawingml/2006/main" xmlns:r="http://schemas.openxmlformats.org/officeDocument/2006/relationships" xmlns:p="http://schemas.openxmlformats.org/presentationml/2006/main">
   <p:cSld>
     <p:bg>
       <p:bgPr>
@@ -10386,7 +10386,7 @@
         <p:cNvPr id="1" name="">
           <a:extLst>
             <a:ext uri="{FF2B5EF4-FFF2-40B4-BE49-F238E27FC236}">
-              <a16:creationId id="{BBFBF43E-80A4-D013-5C64-AD16BBE309A9}"/>
+              <a16:creationId xmlns:a16="http://schemas.microsoft.com/office/drawing/2014/main" id="{BBFBF43E-80A4-D013-5C64-AD16BBE309A9}"/>
             </a:ext>
           </a:extLst>
         </p:cNvPr>
@@ -10406,7 +10406,7 @@
           <p:cNvPr id="2" name="TextBox 1">
             <a:extLst>
               <a:ext uri="{FF2B5EF4-FFF2-40B4-BE49-F238E27FC236}">
-                <a16:creationId id="{DF4E743A-E740-B9E8-D400-EA3F32FF1D55}"/>
+                <a16:creationId xmlns:a16="http://schemas.microsoft.com/office/drawing/2014/main" id="{DF4E743A-E740-B9E8-D400-EA3F32FF1D55}"/>
               </a:ext>
             </a:extLst>
           </p:cNvPr>
@@ -10502,7 +10502,7 @@
           <p:cNvPr id="5" name="TextBox 4">
             <a:extLst>
               <a:ext uri="{FF2B5EF4-FFF2-40B4-BE49-F238E27FC236}">
-                <a16:creationId id="{42082ECC-CEEB-D2B8-60C0-FAF5A1857737}"/>
+                <a16:creationId xmlns:a16="http://schemas.microsoft.com/office/drawing/2014/main" id="{42082ECC-CEEB-D2B8-60C0-FAF5A1857737}"/>
               </a:ext>
             </a:extLst>
           </p:cNvPr>
@@ -11576,7 +11576,7 @@
     </p:spTree>
     <p:extLst>
       <p:ext uri="{BB962C8B-B14F-4D97-AF65-F5344CB8AC3E}">
-        <ns3:creationId val="3863008067"/>
+        <p14:creationId xmlns:p14="http://schemas.microsoft.com/office/powerpoint/2010/main" val="3863008067"/>
       </p:ext>
     </p:extLst>
   </p:cSld>
@@ -11587,7 +11587,7 @@
 </file>
 
 <file path=ppt/slides/slide5.xml><?xml version="1.0" encoding="utf-8"?>
-<p:sld xmlns:a="http://schemas.openxmlformats.org/drawingml/2006/main" xmlns:a16="http://schemas.microsoft.com/office/drawing/2014/main" xmlns:ns3="http://schemas.microsoft.com/office/powerpoint/2010/main" xmlns:ns4="http://schemas.openxmlformats.org/drawingml/2006/diagram" xmlns:p="http://schemas.openxmlformats.org/presentationml/2006/main" xmlns:r="http://schemas.openxmlformats.org/officeDocument/2006/relationships">
+<p:sld xmlns:a="http://schemas.openxmlformats.org/drawingml/2006/main" xmlns:r="http://schemas.openxmlformats.org/officeDocument/2006/relationships" xmlns:p="http://schemas.openxmlformats.org/presentationml/2006/main">
   <p:cSld>
     <p:bg>
       <p:bgPr>
@@ -11602,7 +11602,7 @@
         <p:cNvPr id="1" name="">
           <a:extLst>
             <a:ext uri="{FF2B5EF4-FFF2-40B4-BE49-F238E27FC236}">
-              <a16:creationId id="{1453722B-3781-0E08-25A9-7EDF71C96246}"/>
+              <a16:creationId xmlns:a16="http://schemas.microsoft.com/office/drawing/2014/main" id="{1453722B-3781-0E08-25A9-7EDF71C96246}"/>
             </a:ext>
           </a:extLst>
         </p:cNvPr>
@@ -11622,7 +11622,7 @@
           <p:cNvPr id="3" name="Diagram 2">
             <a:extLst>
               <a:ext uri="{FF2B5EF4-FFF2-40B4-BE49-F238E27FC236}">
-                <a16:creationId id="{64AD777F-D0D7-80D3-EA3B-8A560D8BC354}"/>
+                <a16:creationId xmlns:a16="http://schemas.microsoft.com/office/drawing/2014/main" id="{64AD777F-D0D7-80D3-EA3B-8A560D8BC354}"/>
               </a:ext>
             </a:extLst>
           </p:cNvPr>
@@ -11630,7 +11630,7 @@
           <p:nvPr>
             <p:extLst>
               <p:ext uri="{D42A27DB-BD31-4B8C-83A1-F6EECF244321}">
-                <ns3:modId val="4232438656"/>
+                <p14:modId xmlns:p14="http://schemas.microsoft.com/office/powerpoint/2010/main" val="4232438656"/>
               </p:ext>
             </p:extLst>
           </p:nvPr>
@@ -11641,7 +11641,7 @@
         </p:xfrm>
         <a:graphic>
           <a:graphicData uri="http://schemas.openxmlformats.org/drawingml/2006/diagram">
-            <ns4:relIds r:dm="rId3" r:lo="rId4" r:qs="rId5" r:cs="rId6"/>
+            <dgm:relIds xmlns:dgm="http://schemas.openxmlformats.org/drawingml/2006/diagram" xmlns:r="http://schemas.openxmlformats.org/officeDocument/2006/relationships" r:dm="rId3" r:lo="rId4" r:qs="rId5" r:cs="rId6"/>
           </a:graphicData>
         </a:graphic>
       </p:graphicFrame>
@@ -11650,7 +11650,7 @@
           <p:cNvPr id="4" name="TextBox 3">
             <a:extLst>
               <a:ext uri="{FF2B5EF4-FFF2-40B4-BE49-F238E27FC236}">
-                <a16:creationId id="{8B0D959F-1F8C-C85F-60B5-2379D17C87E3}"/>
+                <a16:creationId xmlns:a16="http://schemas.microsoft.com/office/drawing/2014/main" id="{8B0D959F-1F8C-C85F-60B5-2379D17C87E3}"/>
               </a:ext>
             </a:extLst>
           </p:cNvPr>
@@ -12025,7 +12025,7 @@
     </p:spTree>
     <p:extLst>
       <p:ext uri="{BB962C8B-B14F-4D97-AF65-F5344CB8AC3E}">
-        <ns3:creationId val="213017330"/>
+        <p14:creationId xmlns:p14="http://schemas.microsoft.com/office/powerpoint/2010/main" val="213017330"/>
       </p:ext>
     </p:extLst>
   </p:cSld>

</xml_diff>